<commit_message>
docs(presentation): update PPTX and PDF to focus strictly on project name and description
</commit_message>
<xml_diff>
--- a/NyayaSetu_Presentation.pptx
+++ b/NyayaSetu_Presentation.pptx
@@ -3191,8 +3191,8 @@
         </p:nvSpPr>
         <p:spPr>
           <a:xfrm>
-            <a:off x="914400" y="1371600"/>
-            <a:ext cx="10362895" cy="2011680"/>
+            <a:off x="914400" y="1188720"/>
+            <a:ext cx="10362895" cy="2103120"/>
           </a:xfrm>
           <a:prstGeom prst="rect">
             <a:avLst/>
@@ -3209,7 +3209,7 @@
               <a:spcAft>
                 <a:spcPts val="1000"/>
               </a:spcAft>
-              <a:defRPr sz="4400" b="1">
+              <a:defRPr sz="4600" b="1">
                 <a:solidFill>
                   <a:srgbClr val="FFFFFF"/>
                 </a:solidFill>
@@ -3243,8 +3243,8 @@
         </p:nvSpPr>
         <p:spPr>
           <a:xfrm>
-            <a:off x="914400" y="3840480"/>
-            <a:ext cx="10362895" cy="2011680"/>
+            <a:off x="914400" y="3657600"/>
+            <a:ext cx="10362895" cy="2377440"/>
           </a:xfrm>
           <a:prstGeom prst="roundRect">
             <a:avLst/>
@@ -3288,15 +3288,15 @@
               </a:defRPr>
             </a:pPr>
             <a:r>
-              <a:t>Master of Computer Applications (MCA) — Semester IV Project Presentation</a:t>
-            </a:r>
-          </a:p>
-          <a:p>
-            <a:pPr>
-              <a:spcAft>
-                <a:spcPts val="400"/>
-              </a:spcAft>
-              <a:defRPr sz="1600" b="1">
+              <a:t>PROJECT OVERVIEW &amp; CORE MISSION</a:t>
+            </a:r>
+          </a:p>
+          <a:p>
+            <a:pPr>
+              <a:spcAft>
+                <a:spcPts val="600"/>
+              </a:spcAft>
+              <a:defRPr sz="1400">
                 <a:solidFill>
                   <a:srgbClr val="FFFFFF"/>
                 </a:solidFill>
@@ -3304,15 +3304,15 @@
               </a:defRPr>
             </a:pPr>
             <a:r>
-              <a:t>Student / Developer:  Anush S (Reg. No. 2024903003)</a:t>
-            </a:r>
-          </a:p>
-          <a:p>
-            <a:pPr>
-              <a:spcAft>
-                <a:spcPts val="400"/>
-              </a:spcAft>
-              <a:defRPr sz="1400">
+              <a:t>• An AI-powered legal empowerment and civic access platform tailored specifically for Indian citizens.</a:t>
+            </a:r>
+          </a:p>
+          <a:p>
+            <a:pPr>
+              <a:spcAft>
+                <a:spcPts val="600"/>
+              </a:spcAft>
+              <a:defRPr sz="1300">
                 <a:solidFill>
                   <a:srgbClr val="E2E8F0"/>
                 </a:solidFill>
@@ -3320,20 +3320,20 @@
               </a:defRPr>
             </a:pPr>
             <a:r>
-              <a:t>Project Guide:  Dr. M. Vijayalakshmi, Associate Professor</a:t>
+              <a:t>• Bridges the Justice Gap by translating dense statutes (BNS 2023, BNSS 2023, Consumer Act, RERA) into actionable, plain-language legal guidance.</a:t>
             </a:r>
           </a:p>
           <a:p>
             <a:pPr>
               <a:defRPr sz="1300">
                 <a:solidFill>
-                  <a:srgbClr val="94A3B8"/>
-                </a:solidFill>
-                <a:latin typeface="Calibri"/>
-              </a:defRPr>
-            </a:pPr>
-            <a:r>
-              <a:t>Institution:  Department of Information Science and Technology, Anna University, Chennai</a:t>
+                  <a:srgbClr val="CBD5E1"/>
+                </a:solidFill>
+                <a:latin typeface="Calibri"/>
+              </a:defRPr>
+            </a:pPr>
+            <a:r>
+              <a:t>• Features a 100% Free AI Gateway (Groq Llama 3.3 70B &amp; Gemini 1.5 Flash), Ground-Truth Statutory Reasoning, 25+ Welfare Schemes Navigator, and 1-Click Legal Document Drafter.</a:t>
             </a:r>
           </a:p>
         </p:txBody>
@@ -3473,7 +3473,7 @@
               </a:defRPr>
             </a:pPr>
             <a:r>
-              <a:t>NYAYASETU • MCA PROJECT PRESENTATION</a:t>
+              <a:t>NYAYASETU • CIVIC AI &amp; LEGAL EMPOWERMENT</a:t>
             </a:r>
           </a:p>
         </p:txBody>
@@ -3523,7 +3523,7 @@
         <p:spPr>
           <a:xfrm>
             <a:off x="731520" y="6446520"/>
-            <a:ext cx="7315200" cy="320040"/>
+            <a:ext cx="8686800" cy="320040"/>
           </a:xfrm>
           <a:prstGeom prst="rect">
             <a:avLst/>
@@ -3545,7 +3545,7 @@
               </a:defRPr>
             </a:pPr>
             <a:r>
-              <a:t>NyayaSetu — AI Connecting Citizens with Legal Rights &amp; Government Services | Anna University</a:t>
+              <a:t>NyayaSetu — AI Connecting Citizens with Legal Rights &amp; Government Services</a:t>
             </a:r>
           </a:p>
         </p:txBody>
@@ -3981,7 +3981,7 @@
               </a:defRPr>
             </a:pPr>
             <a:r>
-              <a:t>NYAYASETU • MCA PROJECT PRESENTATION</a:t>
+              <a:t>NYAYASETU • CIVIC AI &amp; LEGAL EMPOWERMENT</a:t>
             </a:r>
           </a:p>
         </p:txBody>
@@ -4031,7 +4031,7 @@
         <p:spPr>
           <a:xfrm>
             <a:off x="731520" y="6446520"/>
-            <a:ext cx="7315200" cy="320040"/>
+            <a:ext cx="8686800" cy="320040"/>
           </a:xfrm>
           <a:prstGeom prst="rect">
             <a:avLst/>
@@ -4053,7 +4053,7 @@
               </a:defRPr>
             </a:pPr>
             <a:r>
-              <a:t>NyayaSetu — AI Connecting Citizens with Legal Rights &amp; Government Services | Anna University</a:t>
+              <a:t>NyayaSetu — AI Connecting Citizens with Legal Rights &amp; Government Services</a:t>
             </a:r>
           </a:p>
         </p:txBody>
@@ -4547,7 +4547,7 @@
               </a:defRPr>
             </a:pPr>
             <a:r>
-              <a:t>NYAYASETU • MCA PROJECT PRESENTATION</a:t>
+              <a:t>NYAYASETU • CIVIC AI &amp; LEGAL EMPOWERMENT</a:t>
             </a:r>
           </a:p>
         </p:txBody>
@@ -4597,7 +4597,7 @@
         <p:spPr>
           <a:xfrm>
             <a:off x="731520" y="6446520"/>
-            <a:ext cx="7315200" cy="320040"/>
+            <a:ext cx="8686800" cy="320040"/>
           </a:xfrm>
           <a:prstGeom prst="rect">
             <a:avLst/>
@@ -4619,7 +4619,7 @@
               </a:defRPr>
             </a:pPr>
             <a:r>
-              <a:t>NyayaSetu — AI Connecting Citizens with Legal Rights &amp; Government Services | Anna University</a:t>
+              <a:t>NyayaSetu — AI Connecting Citizens with Legal Rights &amp; Government Services</a:t>
             </a:r>
           </a:p>
         </p:txBody>
@@ -5113,7 +5113,7 @@
               </a:defRPr>
             </a:pPr>
             <a:r>
-              <a:t>NYAYASETU • MCA PROJECT PRESENTATION</a:t>
+              <a:t>NYAYASETU • CIVIC AI &amp; LEGAL EMPOWERMENT</a:t>
             </a:r>
           </a:p>
         </p:txBody>
@@ -5163,7 +5163,7 @@
         <p:spPr>
           <a:xfrm>
             <a:off x="731520" y="6446520"/>
-            <a:ext cx="7315200" cy="320040"/>
+            <a:ext cx="8686800" cy="320040"/>
           </a:xfrm>
           <a:prstGeom prst="rect">
             <a:avLst/>
@@ -5185,7 +5185,7 @@
               </a:defRPr>
             </a:pPr>
             <a:r>
-              <a:t>NyayaSetu — AI Connecting Citizens with Legal Rights &amp; Government Services | Anna University</a:t>
+              <a:t>NyayaSetu — AI Connecting Citizens with Legal Rights &amp; Government Services</a:t>
             </a:r>
           </a:p>
         </p:txBody>
@@ -5711,7 +5711,7 @@
               </a:defRPr>
             </a:pPr>
             <a:r>
-              <a:t>NYAYASETU • MCA PROJECT PRESENTATION</a:t>
+              <a:t>NYAYASETU • CIVIC AI &amp; LEGAL EMPOWERMENT</a:t>
             </a:r>
           </a:p>
         </p:txBody>
@@ -5761,7 +5761,7 @@
         <p:spPr>
           <a:xfrm>
             <a:off x="731520" y="6446520"/>
-            <a:ext cx="7315200" cy="320040"/>
+            <a:ext cx="8686800" cy="320040"/>
           </a:xfrm>
           <a:prstGeom prst="rect">
             <a:avLst/>
@@ -5783,7 +5783,7 @@
               </a:defRPr>
             </a:pPr>
             <a:r>
-              <a:t>NyayaSetu — AI Connecting Citizens with Legal Rights &amp; Government Services | Anna University</a:t>
+              <a:t>NyayaSetu — AI Connecting Citizens with Legal Rights &amp; Government Services</a:t>
             </a:r>
           </a:p>
         </p:txBody>
@@ -6267,7 +6267,7 @@
               </a:defRPr>
             </a:pPr>
             <a:r>
-              <a:t>NYAYASETU • MCA PROJECT PRESENTATION</a:t>
+              <a:t>NYAYASETU • CIVIC AI &amp; LEGAL EMPOWERMENT</a:t>
             </a:r>
           </a:p>
         </p:txBody>
@@ -6317,7 +6317,7 @@
         <p:spPr>
           <a:xfrm>
             <a:off x="731520" y="6446520"/>
-            <a:ext cx="7315200" cy="320040"/>
+            <a:ext cx="8686800" cy="320040"/>
           </a:xfrm>
           <a:prstGeom prst="rect">
             <a:avLst/>
@@ -6339,7 +6339,7 @@
               </a:defRPr>
             </a:pPr>
             <a:r>
-              <a:t>NyayaSetu — AI Connecting Citizens with Legal Rights &amp; Government Services | Anna University</a:t>
+              <a:t>NyayaSetu — AI Connecting Citizens with Legal Rights &amp; Government Services</a:t>
             </a:r>
           </a:p>
         </p:txBody>
@@ -6823,7 +6823,7 @@
               </a:defRPr>
             </a:pPr>
             <a:r>
-              <a:t>NYAYASETU • MCA PROJECT PRESENTATION</a:t>
+              <a:t>NYAYASETU • CIVIC AI &amp; LEGAL EMPOWERMENT</a:t>
             </a:r>
           </a:p>
         </p:txBody>
@@ -6873,7 +6873,7 @@
         <p:spPr>
           <a:xfrm>
             <a:off x="731520" y="6446520"/>
-            <a:ext cx="7315200" cy="320040"/>
+            <a:ext cx="8686800" cy="320040"/>
           </a:xfrm>
           <a:prstGeom prst="rect">
             <a:avLst/>
@@ -6895,7 +6895,7 @@
               </a:defRPr>
             </a:pPr>
             <a:r>
-              <a:t>NyayaSetu — AI Connecting Citizens with Legal Rights &amp; Government Services | Anna University</a:t>
+              <a:t>NyayaSetu — AI Connecting Citizens with Legal Rights &amp; Government Services</a:t>
             </a:r>
           </a:p>
         </p:txBody>
@@ -7347,7 +7347,7 @@
               </a:defRPr>
             </a:pPr>
             <a:r>
-              <a:t>NYAYASETU • MCA PROJECT PRESENTATION</a:t>
+              <a:t>NYAYASETU • CIVIC AI &amp; LEGAL EMPOWERMENT</a:t>
             </a:r>
           </a:p>
         </p:txBody>
@@ -7397,7 +7397,7 @@
         <p:spPr>
           <a:xfrm>
             <a:off x="731520" y="6446520"/>
-            <a:ext cx="7315200" cy="320040"/>
+            <a:ext cx="8686800" cy="320040"/>
           </a:xfrm>
           <a:prstGeom prst="rect">
             <a:avLst/>
@@ -7419,7 +7419,7 @@
               </a:defRPr>
             </a:pPr>
             <a:r>
-              <a:t>NyayaSetu — AI Connecting Citizens with Legal Rights &amp; Government Services | Anna University</a:t>
+              <a:t>NyayaSetu — AI Connecting Citizens with Legal Rights &amp; Government Services</a:t>
             </a:r>
           </a:p>
         </p:txBody>
@@ -7887,7 +7887,7 @@
               </a:defRPr>
             </a:pPr>
             <a:r>
-              <a:t>NYAYASETU • MCA PROJECT PRESENTATION</a:t>
+              <a:t>NYAYASETU • CIVIC AI &amp; LEGAL EMPOWERMENT</a:t>
             </a:r>
           </a:p>
         </p:txBody>
@@ -7937,7 +7937,7 @@
         <p:spPr>
           <a:xfrm>
             <a:off x="731520" y="6446520"/>
-            <a:ext cx="7315200" cy="320040"/>
+            <a:ext cx="8686800" cy="320040"/>
           </a:xfrm>
           <a:prstGeom prst="rect">
             <a:avLst/>
@@ -7959,7 +7959,7 @@
               </a:defRPr>
             </a:pPr>
             <a:r>
-              <a:t>NyayaSetu — AI Connecting Citizens with Legal Rights &amp; Government Services | Anna University</a:t>
+              <a:t>NyayaSetu — AI Connecting Citizens with Legal Rights &amp; Government Services</a:t>
             </a:r>
           </a:p>
         </p:txBody>

</xml_diff>